<commit_message>
feat(demo): add scripts for demo data generation and cleanup
Introduced new scripts for generating realistic demo data and capturing screenshots for marketing purposes. The `build_demo.mjs` script creates a demo club with players and matches, while `add_history.mjs` populates historical match data. The `capture.mjs` script automates the process of taking screenshots of the app's UI, and `cleanup.mjs` removes all demo data to restore the club to its original state. Additionally, updated the `demo-artifact.json` to track created entities for cleanup.
</commit_message>
<xml_diff>
--- a/marketing/Cap-Track-PZPW.pptx
+++ b/marketing/Cap-Track-PZPW.pptx
@@ -4039,8 +4039,8 @@
         </p:blipFill>
         <p:spPr>
           <a:xfrm>
-            <a:off x="1214472" y="2340864"/>
-            <a:ext cx="5105711" cy="3474720"/>
+            <a:off x="1639948" y="2340864"/>
+            <a:ext cx="4254759" cy="3474720"/>
           </a:xfrm>
           <a:prstGeom prst="rect">
             <a:avLst/>
@@ -4055,8 +4055,8 @@
         </p:nvSpPr>
         <p:spPr>
           <a:xfrm>
-            <a:off x="1214472" y="2340864"/>
-            <a:ext cx="5105711" cy="3474720"/>
+            <a:off x="1639948" y="2340864"/>
+            <a:ext cx="4254759" cy="3474720"/>
           </a:xfrm>
           <a:prstGeom prst="roundRect">
             <a:avLst>
@@ -4815,8 +4815,8 @@
         </p:blipFill>
         <p:spPr>
           <a:xfrm>
-            <a:off x="676656" y="2415844"/>
-            <a:ext cx="5541264" cy="3324758"/>
+            <a:off x="676656" y="2457726"/>
+            <a:ext cx="5541264" cy="3240995"/>
           </a:xfrm>
           <a:prstGeom prst="rect">
             <a:avLst/>
@@ -4831,8 +4831,8 @@
         </p:nvSpPr>
         <p:spPr>
           <a:xfrm>
-            <a:off x="676656" y="2415844"/>
-            <a:ext cx="5541264" cy="3324758"/>
+            <a:off x="676656" y="2457726"/>
+            <a:ext cx="5541264" cy="3240995"/>
           </a:xfrm>
           <a:prstGeom prst="roundRect">
             <a:avLst>
@@ -10685,8 +10685,8 @@
         </p:blipFill>
         <p:spPr>
           <a:xfrm>
-            <a:off x="6899457" y="2295144"/>
-            <a:ext cx="4351924" cy="3566159"/>
+            <a:off x="6892056" y="2295144"/>
+            <a:ext cx="4366726" cy="3566159"/>
           </a:xfrm>
           <a:prstGeom prst="rect">
             <a:avLst/>
@@ -10701,8 +10701,8 @@
         </p:nvSpPr>
         <p:spPr>
           <a:xfrm>
-            <a:off x="6899457" y="2295144"/>
-            <a:ext cx="4351924" cy="3566159"/>
+            <a:off x="6892056" y="2295144"/>
+            <a:ext cx="4366726" cy="3566159"/>
           </a:xfrm>
           <a:prstGeom prst="roundRect">
             <a:avLst>
@@ -13126,8 +13126,8 @@
         </p:blipFill>
         <p:spPr>
           <a:xfrm>
-            <a:off x="1372839" y="2340864"/>
-            <a:ext cx="4240336" cy="3474720"/>
+            <a:off x="1365628" y="2340864"/>
+            <a:ext cx="4254759" cy="3474720"/>
           </a:xfrm>
           <a:prstGeom prst="rect">
             <a:avLst/>
@@ -13142,8 +13142,8 @@
         </p:nvSpPr>
         <p:spPr>
           <a:xfrm>
-            <a:off x="1372839" y="2340864"/>
-            <a:ext cx="4240336" cy="3474720"/>
+            <a:off x="1365628" y="2340864"/>
+            <a:ext cx="4254759" cy="3474720"/>
           </a:xfrm>
           <a:prstGeom prst="roundRect">
             <a:avLst>
@@ -17894,8 +17894,8 @@
         </p:blipFill>
         <p:spPr>
           <a:xfrm>
-            <a:off x="1074746" y="2340864"/>
-            <a:ext cx="4653642" cy="3474720"/>
+            <a:off x="1274188" y="2340864"/>
+            <a:ext cx="4254759" cy="3474720"/>
           </a:xfrm>
           <a:prstGeom prst="rect">
             <a:avLst/>
@@ -17910,8 +17910,8 @@
         </p:nvSpPr>
         <p:spPr>
           <a:xfrm>
-            <a:off x="1074746" y="2340864"/>
-            <a:ext cx="4653642" cy="3474720"/>
+            <a:off x="1274188" y="2340864"/>
+            <a:ext cx="4254759" cy="3474720"/>
           </a:xfrm>
           <a:prstGeom prst="roundRect">
             <a:avLst>

</xml_diff>